<commit_message>
penambahan dokumentasi dan file test
</commit_message>
<xml_diff>
--- a/Dokumentasi Test.pptx
+++ b/Dokumentasi Test.pptx
@@ -5,38 +5,39 @@
     <p:sldMasterId id="2147483648" r:id="rId1"/>
   </p:sldMasterIdLst>
   <p:notesMasterIdLst>
-    <p:notesMasterId r:id="rId14"/>
+    <p:notesMasterId r:id="rId15"/>
   </p:notesMasterIdLst>
   <p:sldIdLst>
     <p:sldId id="256" r:id="rId3"/>
     <p:sldId id="257" r:id="rId4"/>
-    <p:sldId id="258" r:id="rId5"/>
-    <p:sldId id="259" r:id="rId6"/>
-    <p:sldId id="260" r:id="rId7"/>
-    <p:sldId id="261" r:id="rId8"/>
-    <p:sldId id="262" r:id="rId9"/>
-    <p:sldId id="264" r:id="rId10"/>
-    <p:sldId id="263" r:id="rId11"/>
-    <p:sldId id="265" r:id="rId12"/>
-    <p:sldId id="266" r:id="rId13"/>
-    <p:sldId id="267" r:id="rId15"/>
-    <p:sldId id="268" r:id="rId16"/>
-    <p:sldId id="269" r:id="rId17"/>
-    <p:sldId id="271" r:id="rId18"/>
-    <p:sldId id="270" r:id="rId19"/>
-    <p:sldId id="273" r:id="rId20"/>
-    <p:sldId id="272" r:id="rId21"/>
-    <p:sldId id="274" r:id="rId22"/>
-    <p:sldId id="276" r:id="rId23"/>
-    <p:sldId id="278" r:id="rId24"/>
-    <p:sldId id="277" r:id="rId25"/>
-    <p:sldId id="279" r:id="rId26"/>
-    <p:sldId id="280" r:id="rId27"/>
-    <p:sldId id="281" r:id="rId28"/>
-    <p:sldId id="282" r:id="rId29"/>
-    <p:sldId id="283" r:id="rId30"/>
-    <p:sldId id="284" r:id="rId31"/>
-    <p:sldId id="285" r:id="rId32"/>
+    <p:sldId id="286" r:id="rId5"/>
+    <p:sldId id="258" r:id="rId6"/>
+    <p:sldId id="259" r:id="rId7"/>
+    <p:sldId id="260" r:id="rId8"/>
+    <p:sldId id="261" r:id="rId9"/>
+    <p:sldId id="262" r:id="rId10"/>
+    <p:sldId id="264" r:id="rId11"/>
+    <p:sldId id="263" r:id="rId12"/>
+    <p:sldId id="265" r:id="rId13"/>
+    <p:sldId id="266" r:id="rId14"/>
+    <p:sldId id="267" r:id="rId16"/>
+    <p:sldId id="268" r:id="rId17"/>
+    <p:sldId id="269" r:id="rId18"/>
+    <p:sldId id="271" r:id="rId19"/>
+    <p:sldId id="270" r:id="rId20"/>
+    <p:sldId id="273" r:id="rId21"/>
+    <p:sldId id="272" r:id="rId22"/>
+    <p:sldId id="274" r:id="rId23"/>
+    <p:sldId id="276" r:id="rId24"/>
+    <p:sldId id="278" r:id="rId25"/>
+    <p:sldId id="277" r:id="rId26"/>
+    <p:sldId id="279" r:id="rId27"/>
+    <p:sldId id="280" r:id="rId28"/>
+    <p:sldId id="281" r:id="rId29"/>
+    <p:sldId id="282" r:id="rId30"/>
+    <p:sldId id="283" r:id="rId31"/>
+    <p:sldId id="284" r:id="rId32"/>
+    <p:sldId id="285" r:id="rId33"/>
   </p:sldIdLst>
   <p:sldSz cx="12192000" cy="6858000"/>
   <p:notesSz cx="6858000" cy="9144000"/>
@@ -3420,6 +3421,210 @@
       <p:grpSpPr/>
       <p:sp>
         <p:nvSpPr>
+          <p:cNvPr id="2" name="Title 1"/>
+          <p:cNvSpPr>
+            <a:spLocks noGrp="1"/>
+          </p:cNvSpPr>
+          <p:nvPr>
+            <p:ph type="title"/>
+          </p:nvPr>
+        </p:nvSpPr>
+        <p:spPr/>
+        <p:txBody>
+          <a:bodyPr/>
+          <a:p>
+            <a:r>
+              <a:rPr lang="en-US"/>
+              <a:t>API Update Applicants</a:t>
+            </a:r>
+            <a:endParaRPr lang="en-US"/>
+          </a:p>
+        </p:txBody>
+      </p:sp>
+      <p:sp>
+        <p:nvSpPr>
+          <p:cNvPr id="3" name="Content Placeholder 2"/>
+          <p:cNvSpPr>
+            <a:spLocks noGrp="1"/>
+          </p:cNvSpPr>
+          <p:nvPr>
+            <p:ph sz="half" idx="1"/>
+          </p:nvPr>
+        </p:nvSpPr>
+        <p:spPr/>
+        <p:txBody>
+          <a:bodyPr>
+            <a:normAutofit fontScale="60000"/>
+          </a:bodyPr>
+          <a:p>
+            <a:r>
+              <a:rPr lang="en-US">
+                <a:sym typeface="+mn-ea"/>
+              </a:rPr>
+              <a:t>Api untuk mengupdate data aplicants</a:t>
+            </a:r>
+            <a:endParaRPr lang="en-US">
+              <a:sym typeface="+mn-ea"/>
+            </a:endParaRPr>
+          </a:p>
+          <a:p>
+            <a:r>
+              <a:rPr lang="en-US">
+                <a:sym typeface="+mn-ea"/>
+              </a:rPr>
+              <a:t>Method POST</a:t>
+            </a:r>
+            <a:endParaRPr lang="en-US"/>
+          </a:p>
+          <a:p>
+            <a:r>
+              <a:rPr lang="en-US">
+                <a:sym typeface="+mn-ea"/>
+              </a:rPr>
+              <a:t>URL:</a:t>
+            </a:r>
+            <a:br>
+              <a:rPr lang="en-US">
+                <a:sym typeface="+mn-ea"/>
+              </a:rPr>
+            </a:br>
+            <a:r>
+              <a:rPr lang="en-US">
+                <a:sym typeface="+mn-ea"/>
+              </a:rPr>
+              <a:t>localhost:3000/applicants/&lt;id applicants&gt;</a:t>
+            </a:r>
+            <a:endParaRPr lang="en-US">
+              <a:sym typeface="+mn-ea"/>
+            </a:endParaRPr>
+          </a:p>
+          <a:p>
+            <a:r>
+              <a:rPr lang="en-US">
+                <a:sym typeface="+mn-ea"/>
+              </a:rPr>
+              <a:t>Contoh url:</a:t>
+            </a:r>
+            <a:br>
+              <a:rPr lang="en-US">
+                <a:sym typeface="+mn-ea"/>
+              </a:rPr>
+            </a:br>
+            <a:r>
+              <a:rPr lang="en-US">
+                <a:sym typeface="+mn-ea"/>
+              </a:rPr>
+              <a:t>localhost:3000/applicants/11</a:t>
+            </a:r>
+            <a:endParaRPr lang="en-US"/>
+          </a:p>
+          <a:p>
+            <a:r>
+              <a:rPr lang="en-US" altLang="en-US">
+                <a:sym typeface="+mn-ea"/>
+              </a:rPr>
+              <a:t>Contoh body:</a:t>
+            </a:r>
+            <a:endParaRPr lang="en-US" altLang="en-US"/>
+          </a:p>
+          <a:p>
+            <a:pPr marL="0" indent="0">
+              <a:buNone/>
+            </a:pPr>
+            <a:r>
+              <a:rPr lang="en-US" altLang="en-US"/>
+              <a:t>{</a:t>
+            </a:r>
+            <a:endParaRPr lang="en-US" altLang="en-US"/>
+          </a:p>
+          <a:p>
+            <a:pPr marL="0" indent="0">
+              <a:buNone/>
+            </a:pPr>
+            <a:r>
+              <a:rPr lang="en-US" altLang="en-US"/>
+              <a:t>    "name": "Joshua Kevin Updated",</a:t>
+            </a:r>
+            <a:endParaRPr lang="en-US" altLang="en-US"/>
+          </a:p>
+          <a:p>
+            <a:pPr marL="0" indent="0">
+              <a:buNone/>
+            </a:pPr>
+            <a:r>
+              <a:rPr lang="en-US" altLang="en-US"/>
+              <a:t>    "email": "jokevin@example.com",</a:t>
+            </a:r>
+            <a:endParaRPr lang="en-US" altLang="en-US"/>
+          </a:p>
+          <a:p>
+            <a:pPr marL="0" indent="0">
+              <a:buNone/>
+            </a:pPr>
+            <a:r>
+              <a:rPr lang="en-US" altLang="en-US"/>
+              <a:t>    "phone": "081234567891"</a:t>
+            </a:r>
+            <a:endParaRPr lang="en-US" altLang="en-US"/>
+          </a:p>
+          <a:p>
+            <a:pPr marL="0" indent="0">
+              <a:buNone/>
+            </a:pPr>
+            <a:r>
+              <a:rPr lang="en-US" altLang="en-US"/>
+              <a:t>}</a:t>
+            </a:r>
+            <a:endParaRPr lang="en-US" altLang="en-US"/>
+          </a:p>
+        </p:txBody>
+      </p:sp>
+      <p:pic>
+        <p:nvPicPr>
+          <p:cNvPr id="5" name="Content Placeholder 4"/>
+          <p:cNvPicPr>
+            <a:picLocks noChangeAspect="1"/>
+          </p:cNvPicPr>
+          <p:nvPr>
+            <p:ph sz="half" idx="2"/>
+          </p:nvPr>
+        </p:nvPicPr>
+        <p:blipFill>
+          <a:blip r:embed="rId1"/>
+          <a:stretch>
+            <a:fillRect/>
+          </a:stretch>
+        </p:blipFill>
+        <p:spPr>
+          <a:xfrm>
+            <a:off x="6660515" y="1825625"/>
+            <a:ext cx="4204335" cy="4351655"/>
+          </a:xfrm>
+          <a:prstGeom prst="rect">
+            <a:avLst/>
+          </a:prstGeom>
+        </p:spPr>
+      </p:pic>
+    </p:spTree>
+  </p:cSld>
+  <p:clrMapOvr>
+    <a:masterClrMapping/>
+  </p:clrMapOvr>
+</p:sld>
+</file>
+
+<file path=ppt/slides/slide11.xml><?xml version="1.0" encoding="utf-8"?>
+<p:sld xmlns:a="http://schemas.openxmlformats.org/drawingml/2006/main" xmlns:r="http://schemas.openxmlformats.org/officeDocument/2006/relationships" xmlns:p="http://schemas.openxmlformats.org/presentationml/2006/main">
+  <p:cSld>
+    <p:spTree>
+      <p:nvGrpSpPr>
+        <p:cNvPr id="1" name=""/>
+        <p:cNvGrpSpPr/>
+        <p:nvPr/>
+      </p:nvGrpSpPr>
+      <p:grpSpPr/>
+      <p:sp>
+        <p:nvSpPr>
           <p:cNvPr id="5" name="Title 4"/>
           <p:cNvSpPr>
             <a:spLocks noGrp="1"/>
@@ -3478,84 +3683,6 @@
 </p:sld>
 </file>
 
-<file path=ppt/slides/slide11.xml><?xml version="1.0" encoding="utf-8"?>
-<p:sld xmlns:a="http://schemas.openxmlformats.org/drawingml/2006/main" xmlns:r="http://schemas.openxmlformats.org/officeDocument/2006/relationships" xmlns:p="http://schemas.openxmlformats.org/presentationml/2006/main">
-  <p:cSld>
-    <p:spTree>
-      <p:nvGrpSpPr>
-        <p:cNvPr id="1" name=""/>
-        <p:cNvGrpSpPr/>
-        <p:nvPr/>
-      </p:nvGrpSpPr>
-      <p:grpSpPr/>
-      <p:sp>
-        <p:nvSpPr>
-          <p:cNvPr id="5" name="Title 4"/>
-          <p:cNvSpPr>
-            <a:spLocks noGrp="1"/>
-          </p:cNvSpPr>
-          <p:nvPr>
-            <p:ph type="title"/>
-          </p:nvPr>
-        </p:nvSpPr>
-        <p:spPr/>
-        <p:txBody>
-          <a:bodyPr/>
-          <a:p>
-            <a:r>
-              <a:rPr lang="en-US"/>
-              <a:t>Tugas 2 : Scheduler automation</a:t>
-            </a:r>
-            <a:endParaRPr lang="en-US"/>
-          </a:p>
-        </p:txBody>
-      </p:sp>
-      <p:sp>
-        <p:nvSpPr>
-          <p:cNvPr id="6" name="Content Placeholder 5"/>
-          <p:cNvSpPr>
-            <a:spLocks noGrp="1"/>
-          </p:cNvSpPr>
-          <p:nvPr>
-            <p:ph idx="1"/>
-          </p:nvPr>
-        </p:nvSpPr>
-        <p:spPr/>
-        <p:txBody>
-          <a:bodyPr/>
-          <a:p>
-            <a:r>
-              <a:rPr lang="en-US"/>
-              <a:t>Premis:</a:t>
-            </a:r>
-            <a:endParaRPr lang="en-US"/>
-          </a:p>
-          <a:p>
-            <a:pPr lvl="1"/>
-            <a:r>
-              <a:rPr lang="en-US"/>
-              <a:t>Untuk kebutuhan test dan kenyamanan test, folder /home/cron yang dijadikan penilaian saya masukkan ke volumes pada docker untuk menjaga konsistensi hasil</a:t>
-            </a:r>
-            <a:endParaRPr lang="en-US"/>
-          </a:p>
-          <a:p>
-            <a:pPr lvl="1"/>
-            <a:r>
-              <a:rPr lang="en-US"/>
-              <a:t>jika memang dibutuhkan agar masuk ke /home/cron, saya sudah sediakan file konfigurasi khusus production yang mengatur agar volumenya benar benar di bind ke /home/cron </a:t>
-            </a:r>
-            <a:endParaRPr lang="en-US"/>
-          </a:p>
-        </p:txBody>
-      </p:sp>
-    </p:spTree>
-  </p:cSld>
-  <p:clrMapOvr>
-    <a:masterClrMapping/>
-  </p:clrMapOvr>
-</p:sld>
-</file>
-
 <file path=ppt/slides/slide12.xml><?xml version="1.0" encoding="utf-8"?>
 <p:sld xmlns:a="http://schemas.openxmlformats.org/drawingml/2006/main" xmlns:r="http://schemas.openxmlformats.org/officeDocument/2006/relationships" xmlns:p="http://schemas.openxmlformats.org/presentationml/2006/main">
   <p:cSld>
@@ -3568,7 +3695,7 @@
       <p:grpSpPr/>
       <p:sp>
         <p:nvSpPr>
-          <p:cNvPr id="2" name="Title 1"/>
+          <p:cNvPr id="5" name="Title 4"/>
           <p:cNvSpPr>
             <a:spLocks noGrp="1"/>
           </p:cNvSpPr>
@@ -3582,15 +3709,15 @@
           <a:p>
             <a:r>
               <a:rPr lang="en-US"/>
-              <a:t>Scripts</a:t>
-            </a:r>
-            <a:endParaRPr lang="en-US"/>
-          </a:p>
-        </p:txBody>
-      </p:sp>
-      <p:sp>
-        <p:nvSpPr>
-          <p:cNvPr id="3" name="Content Placeholder 2"/>
+              <a:t>Tugas 2 : Scheduler automation</a:t>
+            </a:r>
+            <a:endParaRPr lang="en-US"/>
+          </a:p>
+        </p:txBody>
+      </p:sp>
+      <p:sp>
+        <p:nvSpPr>
+          <p:cNvPr id="6" name="Content Placeholder 5"/>
           <p:cNvSpPr>
             <a:spLocks noGrp="1"/>
           </p:cNvSpPr>
@@ -3600,27 +3727,27 @@
         </p:nvSpPr>
         <p:spPr/>
         <p:txBody>
-          <a:bodyPr>
-            <a:normAutofit lnSpcReduction="10000"/>
-          </a:bodyPr>
-          <a:p>
-            <a:r>
-              <a:rPr lang="en-US"/>
-              <a:t>semua scripts masuk pada folder scripts dan diintegrasikan dengan nodejs, berupa masuknya file scripts pada package.json dan dapat dipanggil menggunakan npm pada root project folder</a:t>
-            </a:r>
-            <a:endParaRPr lang="en-US"/>
-          </a:p>
-          <a:p>
-            <a:r>
-              <a:rPr lang="en-US"/>
-              <a:t>Command “npm run collect” menjalankan scripts pada ./scripts/collectdata.js</a:t>
-            </a:r>
-            <a:endParaRPr lang="en-US"/>
-          </a:p>
-          <a:p>
-            <a:r>
-              <a:rPr lang="en-US"/>
-              <a:t>Command “npm run clean” menjalankan scripts pada ./scripts/dataclean.js</a:t>
+          <a:bodyPr/>
+          <a:p>
+            <a:r>
+              <a:rPr lang="en-US"/>
+              <a:t>Premis:</a:t>
+            </a:r>
+            <a:endParaRPr lang="en-US"/>
+          </a:p>
+          <a:p>
+            <a:pPr lvl="1"/>
+            <a:r>
+              <a:rPr lang="en-US"/>
+              <a:t>Untuk kebutuhan test dan kenyamanan test, folder /home/cron yang dijadikan penilaian saya masukkan ke volumes pada docker untuk menjaga konsistensi hasil</a:t>
+            </a:r>
+            <a:endParaRPr lang="en-US"/>
+          </a:p>
+          <a:p>
+            <a:pPr lvl="1"/>
+            <a:r>
+              <a:rPr lang="en-US"/>
+              <a:t>jika memang dibutuhkan agar masuk ke /home/cron, saya sudah sediakan file konfigurasi khusus production yang mengatur agar volumenya benar benar di bind ke /home/cron </a:t>
             </a:r>
             <a:endParaRPr lang="en-US"/>
           </a:p>
@@ -3660,7 +3787,7 @@
           <a:p>
             <a:r>
               <a:rPr lang="en-US"/>
-              <a:t>Crontab </a:t>
+              <a:t>Scripts</a:t>
             </a:r>
             <a:endParaRPr lang="en-US"/>
           </a:p>
@@ -3678,34 +3805,27 @@
         </p:nvSpPr>
         <p:spPr/>
         <p:txBody>
-          <a:bodyPr/>
-          <a:p>
-            <a:r>
-              <a:rPr lang="en-US"/>
-              <a:t>karena adanya kebutuhan untuk membaca database dan keterbatasan waktu, maka crontab saat ini bagian atas harus menyertakan env database_url selain dari crontab yang dibutuhkan</a:t>
-            </a:r>
-            <a:endParaRPr lang="en-US"/>
-          </a:p>
-          <a:p>
-            <a:r>
-              <a:rPr lang="en-US"/>
-              <a:t>Syntax Cron config yang digunakan: </a:t>
-            </a:r>
-            <a:endParaRPr lang="en-US"/>
-          </a:p>
-          <a:p>
-            <a:pPr lvl="1"/>
-            <a:r>
-              <a:rPr lang="en-US"/>
-              <a:t>tiap jam 8,12,15 menjalankan npm run collect</a:t>
-            </a:r>
-            <a:endParaRPr lang="en-US"/>
-          </a:p>
-          <a:p>
-            <a:pPr lvl="1"/>
-            <a:r>
-              <a:rPr lang="en-US"/>
-              <a:t>tiap menit menjalankan npm run clean</a:t>
+          <a:bodyPr>
+            <a:normAutofit lnSpcReduction="10000"/>
+          </a:bodyPr>
+          <a:p>
+            <a:r>
+              <a:rPr lang="en-US"/>
+              <a:t>semua scripts masuk pada folder scripts dan diintegrasikan dengan nodejs, berupa masuknya file scripts pada package.json dan dapat dipanggil menggunakan npm pada root project folder</a:t>
+            </a:r>
+            <a:endParaRPr lang="en-US"/>
+          </a:p>
+          <a:p>
+            <a:r>
+              <a:rPr lang="en-US"/>
+              <a:t>Command “npm run collect” menjalankan scripts pada ./scripts/collectdata.js</a:t>
+            </a:r>
+            <a:endParaRPr lang="en-US"/>
+          </a:p>
+          <a:p>
+            <a:r>
+              <a:rPr lang="en-US"/>
+              <a:t>Command “npm run clean” menjalankan scripts pada ./scripts/dataclean.js</a:t>
             </a:r>
             <a:endParaRPr lang="en-US"/>
           </a:p>
@@ -3720,6 +3840,91 @@
 </file>
 
 <file path=ppt/slides/slide14.xml><?xml version="1.0" encoding="utf-8"?>
+<p:sld xmlns:a="http://schemas.openxmlformats.org/drawingml/2006/main" xmlns:r="http://schemas.openxmlformats.org/officeDocument/2006/relationships" xmlns:p="http://schemas.openxmlformats.org/presentationml/2006/main">
+  <p:cSld>
+    <p:spTree>
+      <p:nvGrpSpPr>
+        <p:cNvPr id="1" name=""/>
+        <p:cNvGrpSpPr/>
+        <p:nvPr/>
+      </p:nvGrpSpPr>
+      <p:grpSpPr/>
+      <p:sp>
+        <p:nvSpPr>
+          <p:cNvPr id="2" name="Title 1"/>
+          <p:cNvSpPr>
+            <a:spLocks noGrp="1"/>
+          </p:cNvSpPr>
+          <p:nvPr>
+            <p:ph type="title"/>
+          </p:nvPr>
+        </p:nvSpPr>
+        <p:spPr/>
+        <p:txBody>
+          <a:bodyPr/>
+          <a:p>
+            <a:r>
+              <a:rPr lang="en-US"/>
+              <a:t>Crontab </a:t>
+            </a:r>
+            <a:endParaRPr lang="en-US"/>
+          </a:p>
+        </p:txBody>
+      </p:sp>
+      <p:sp>
+        <p:nvSpPr>
+          <p:cNvPr id="3" name="Content Placeholder 2"/>
+          <p:cNvSpPr>
+            <a:spLocks noGrp="1"/>
+          </p:cNvSpPr>
+          <p:nvPr>
+            <p:ph idx="1"/>
+          </p:nvPr>
+        </p:nvSpPr>
+        <p:spPr/>
+        <p:txBody>
+          <a:bodyPr/>
+          <a:p>
+            <a:r>
+              <a:rPr lang="en-US"/>
+              <a:t>karena adanya kebutuhan untuk membaca database dan keterbatasan waktu, maka crontab saat ini bagian atas harus menyertakan env database_url selain dari crontab yang dibutuhkan</a:t>
+            </a:r>
+            <a:endParaRPr lang="en-US"/>
+          </a:p>
+          <a:p>
+            <a:r>
+              <a:rPr lang="en-US"/>
+              <a:t>Syntax Cron config yang digunakan: </a:t>
+            </a:r>
+            <a:endParaRPr lang="en-US"/>
+          </a:p>
+          <a:p>
+            <a:pPr lvl="1"/>
+            <a:r>
+              <a:rPr lang="en-US"/>
+              <a:t>tiap jam 8,12,15 menjalankan npm run collect</a:t>
+            </a:r>
+            <a:endParaRPr lang="en-US"/>
+          </a:p>
+          <a:p>
+            <a:pPr lvl="1"/>
+            <a:r>
+              <a:rPr lang="en-US"/>
+              <a:t>tiap menit menjalankan npm run clean</a:t>
+            </a:r>
+            <a:endParaRPr lang="en-US"/>
+          </a:p>
+        </p:txBody>
+      </p:sp>
+    </p:spTree>
+  </p:cSld>
+  <p:clrMapOvr>
+    <a:masterClrMapping/>
+  </p:clrMapOvr>
+</p:sld>
+</file>
+
+<file path=ppt/slides/slide15.xml><?xml version="1.0" encoding="utf-8"?>
 <p:sld xmlns:a="http://schemas.openxmlformats.org/drawingml/2006/main" xmlns:r="http://schemas.openxmlformats.org/officeDocument/2006/relationships" xmlns:p="http://schemas.openxmlformats.org/presentationml/2006/main">
   <p:cSld>
     <p:spTree>
@@ -3787,7 +3992,7 @@
 </p:sld>
 </file>
 
-<file path=ppt/slides/slide15.xml><?xml version="1.0" encoding="utf-8"?>
+<file path=ppt/slides/slide16.xml><?xml version="1.0" encoding="utf-8"?>
 <p:sld xmlns:a="http://schemas.openxmlformats.org/drawingml/2006/main" xmlns:r="http://schemas.openxmlformats.org/officeDocument/2006/relationships" xmlns:p="http://schemas.openxmlformats.org/presentationml/2006/main">
   <p:cSld>
     <p:spTree>
@@ -3858,7 +4063,7 @@
 </p:sld>
 </file>
 
-<file path=ppt/slides/slide16.xml><?xml version="1.0" encoding="utf-8"?>
+<file path=ppt/slides/slide17.xml><?xml version="1.0" encoding="utf-8"?>
 <p:sld xmlns:a="http://schemas.openxmlformats.org/drawingml/2006/main" xmlns:r="http://schemas.openxmlformats.org/officeDocument/2006/relationships" xmlns:p="http://schemas.openxmlformats.org/presentationml/2006/main">
   <p:cSld>
     <p:spTree>
@@ -3926,7 +4131,7 @@
 </p:sld>
 </file>
 
-<file path=ppt/slides/slide17.xml><?xml version="1.0" encoding="utf-8"?>
+<file path=ppt/slides/slide18.xml><?xml version="1.0" encoding="utf-8"?>
 <p:sld xmlns:a="http://schemas.openxmlformats.org/drawingml/2006/main" xmlns:r="http://schemas.openxmlformats.org/officeDocument/2006/relationships" xmlns:p="http://schemas.openxmlformats.org/presentationml/2006/main">
   <p:cSld>
     <p:spTree>
@@ -3994,75 +4199,6 @@
 </p:sld>
 </file>
 
-<file path=ppt/slides/slide18.xml><?xml version="1.0" encoding="utf-8"?>
-<p:sld xmlns:a="http://schemas.openxmlformats.org/drawingml/2006/main" xmlns:r="http://schemas.openxmlformats.org/officeDocument/2006/relationships" xmlns:p="http://schemas.openxmlformats.org/presentationml/2006/main">
-  <p:cSld>
-    <p:spTree>
-      <p:nvGrpSpPr>
-        <p:cNvPr id="1" name=""/>
-        <p:cNvGrpSpPr/>
-        <p:nvPr/>
-      </p:nvGrpSpPr>
-      <p:grpSpPr/>
-      <p:sp>
-        <p:nvSpPr>
-          <p:cNvPr id="2" name="Title 1"/>
-          <p:cNvSpPr>
-            <a:spLocks noGrp="1"/>
-          </p:cNvSpPr>
-          <p:nvPr>
-            <p:ph type="title"/>
-          </p:nvPr>
-        </p:nvSpPr>
-        <p:spPr/>
-        <p:txBody>
-          <a:bodyPr/>
-          <a:p>
-            <a:r>
-              <a:rPr lang="en-US"/>
-              <a:t>collectdata.js</a:t>
-            </a:r>
-            <a:endParaRPr lang="en-US"/>
-          </a:p>
-        </p:txBody>
-      </p:sp>
-      <p:sp>
-        <p:nvSpPr>
-          <p:cNvPr id="3" name="Content Placeholder 2"/>
-          <p:cNvSpPr>
-            <a:spLocks noGrp="1"/>
-          </p:cNvSpPr>
-          <p:nvPr>
-            <p:ph idx="1"/>
-          </p:nvPr>
-        </p:nvSpPr>
-        <p:spPr/>
-        <p:txBody>
-          <a:bodyPr/>
-          <a:p>
-            <a:r>
-              <a:rPr lang="en-US"/>
-              <a:t>Scripts ini menjalankan fungsi list applicant yang digunakan pada server, lalu diubah menjadi .csv, disimpan pada /home/cron</a:t>
-            </a:r>
-            <a:endParaRPr lang="en-US"/>
-          </a:p>
-          <a:p>
-            <a:r>
-              <a:rPr lang="en-US"/>
-              <a:t>hasil error atau hasil log yang diberikan disimpan padah /home/cron/collect.log</a:t>
-            </a:r>
-            <a:endParaRPr lang="en-US"/>
-          </a:p>
-        </p:txBody>
-      </p:sp>
-    </p:spTree>
-  </p:cSld>
-  <p:clrMapOvr>
-    <a:masterClrMapping/>
-  </p:clrMapOvr>
-</p:sld>
-</file>
-
 <file path=ppt/slides/slide19.xml><?xml version="1.0" encoding="utf-8"?>
 <p:sld xmlns:a="http://schemas.openxmlformats.org/drawingml/2006/main" xmlns:r="http://schemas.openxmlformats.org/officeDocument/2006/relationships" xmlns:p="http://schemas.openxmlformats.org/presentationml/2006/main">
   <p:cSld>
@@ -4089,7 +4225,7 @@
           <a:p>
             <a:r>
               <a:rPr lang="en-US"/>
-              <a:t>cleandata.js</a:t>
+              <a:t>collectdata.js</a:t>
             </a:r>
             <a:endParaRPr lang="en-US"/>
           </a:p>
@@ -4110,38 +4246,16 @@
           <a:bodyPr/>
           <a:p>
             <a:r>
-              <a:rPr lang="en-US">
-                <a:sym typeface="+mn-ea"/>
-              </a:rPr>
-              <a:t>Scripts ini membuka semua file di /home/cron ,lalu menghapus jika usia data sudah lebih dari 1 bulan atau sesuai kondisi hapus yang digunakan</a:t>
-            </a:r>
-            <a:endParaRPr lang="en-US">
-              <a:sym typeface="+mn-ea"/>
-            </a:endParaRPr>
-          </a:p>
-          <a:p>
-            <a:r>
-              <a:rPr lang="en-US">
-                <a:sym typeface="+mn-ea"/>
-              </a:rPr>
-              <a:t>untuk mengubah kondisi hapus, dapat mengganti pada line “</a:t>
-            </a:r>
-            <a:r>
-              <a:rPr lang="en-US" altLang="en-US"/>
-              <a:t>let deleteCondition = now.diff(fileTime, 'months') &gt; 1;”</a:t>
-            </a:r>
-            <a:endParaRPr lang="en-US" altLang="en-US"/>
-          </a:p>
-          <a:p>
-            <a:r>
-              <a:rPr lang="en-US">
-                <a:sym typeface="+mn-ea"/>
-              </a:rPr>
-              <a:t>hasil error atau hasil log yang diberikan disimpan padah /home/cron/clean.log</a:t>
-            </a:r>
-            <a:endParaRPr lang="en-US"/>
-          </a:p>
-          <a:p>
+              <a:rPr lang="en-US"/>
+              <a:t>Scripts ini menjalankan fungsi list applicant yang digunakan pada server, lalu diubah menjadi .csv, disimpan pada /home/cron</a:t>
+            </a:r>
+            <a:endParaRPr lang="en-US"/>
+          </a:p>
+          <a:p>
+            <a:r>
+              <a:rPr lang="en-US"/>
+              <a:t>hasil error atau hasil log yang diberikan disimpan padah /home/cron/collect.log</a:t>
+            </a:r>
             <a:endParaRPr lang="en-US"/>
           </a:p>
         </p:txBody>
@@ -4289,7 +4403,7 @@
           <a:p>
             <a:r>
               <a:rPr lang="en-US"/>
-              <a:t>Tugas 3 SQL </a:t>
+              <a:t>cleandata.js</a:t>
             </a:r>
             <a:endParaRPr lang="en-US"/>
           </a:p>
@@ -4310,37 +4424,34 @@
           <a:bodyPr/>
           <a:p>
             <a:r>
-              <a:rPr lang="en-US"/>
-              <a:t>tugas sql dikerjakan dengan asumsi db yang berjalan di postgresql</a:t>
-            </a:r>
-            <a:endParaRPr lang="en-US"/>
-          </a:p>
-          <a:p>
-            <a:r>
-              <a:rPr lang="en-US"/>
-              <a:t>untuk kemudahan test, saya menggunakan container db dan scripts tugas yang diberikan saya taruh pada folder db_scripts dan akan di mount langsung ke dalam path /home/db_scripts pada container db</a:t>
-            </a:r>
-            <a:endParaRPr lang="en-US"/>
-          </a:p>
-          <a:p>
-            <a:r>
-              <a:rPr lang="en-US"/>
-              <a:t>penggantian lokasi bisa diganti lewat compose.yaml yang digunakan</a:t>
-            </a:r>
-            <a:endParaRPr lang="en-US"/>
-          </a:p>
-          <a:p>
-            <a:r>
-              <a:rPr lang="en-US"/>
-              <a:t>untuk menjalankan hasil menggunakan db container, bisa menggunakan syntax:</a:t>
-            </a:r>
-            <a:endParaRPr lang="en-US"/>
-          </a:p>
-          <a:p>
-            <a:pPr lvl="1"/>
+              <a:rPr lang="en-US">
+                <a:sym typeface="+mn-ea"/>
+              </a:rPr>
+              <a:t>Scripts ini membuka semua file di /home/cron ,lalu menghapus jika usia data sudah lebih dari 1 bulan atau sesuai kondisi hapus yang digunakan</a:t>
+            </a:r>
+            <a:endParaRPr lang="en-US">
+              <a:sym typeface="+mn-ea"/>
+            </a:endParaRPr>
+          </a:p>
+          <a:p>
+            <a:r>
+              <a:rPr lang="en-US">
+                <a:sym typeface="+mn-ea"/>
+              </a:rPr>
+              <a:t>untuk mengubah kondisi hapus, dapat mengganti pada line “</a:t>
+            </a:r>
             <a:r>
               <a:rPr lang="en-US" altLang="en-US"/>
-              <a:t>docker exec -i hr_app_db psql -U app -d appdatabase -f /home/db_scripts/(nama file, misal task1.sql)</a:t>
+              <a:t>let deleteCondition = now.diff(fileTime, 'months') &gt; 1;”</a:t>
+            </a:r>
+            <a:endParaRPr lang="en-US" altLang="en-US"/>
+          </a:p>
+          <a:p>
+            <a:r>
+              <a:rPr lang="en-US">
+                <a:sym typeface="+mn-ea"/>
+              </a:rPr>
+              <a:t>hasil error atau hasil log yang diberikan disimpan padah /home/cron/clean.log</a:t>
             </a:r>
             <a:endParaRPr lang="en-US"/>
           </a:p>
@@ -4379,13 +4490,11 @@
         </p:nvSpPr>
         <p:spPr/>
         <p:txBody>
-          <a:bodyPr>
-            <a:normAutofit fontScale="90000"/>
-          </a:bodyPr>
-          <a:p>
-            <a:r>
-              <a:rPr lang="en-US"/>
-              <a:t>asumsi tabel staff dengan sql create table sebagai berikut</a:t>
+          <a:bodyPr/>
+          <a:p>
+            <a:r>
+              <a:rPr lang="en-US"/>
+              <a:t>Tugas 3 SQL </a:t>
             </a:r>
             <a:endParaRPr lang="en-US"/>
           </a:p>
@@ -4403,101 +4512,45 @@
         </p:nvSpPr>
         <p:spPr/>
         <p:txBody>
-          <a:bodyPr>
-            <a:normAutofit lnSpcReduction="10000"/>
-          </a:bodyPr>
-          <a:p>
-            <a:pPr marL="0" indent="0">
-              <a:buNone/>
-            </a:pPr>
+          <a:bodyPr/>
+          <a:p>
+            <a:r>
+              <a:rPr lang="en-US"/>
+              <a:t>tugas sql dikerjakan dengan asumsi db yang berjalan di postgresql</a:t>
+            </a:r>
+            <a:endParaRPr lang="en-US"/>
+          </a:p>
+          <a:p>
+            <a:r>
+              <a:rPr lang="en-US"/>
+              <a:t>untuk kemudahan test, saya menggunakan container db dan scripts tugas yang diberikan saya taruh pada folder db_scripts dan akan di mount langsung ke dalam path /home/db_scripts pada container db</a:t>
+            </a:r>
+            <a:endParaRPr lang="en-US"/>
+          </a:p>
+          <a:p>
+            <a:r>
+              <a:rPr lang="en-US"/>
+              <a:t>penggantian lokasi bisa diganti lewat compose.yaml yang digunakan</a:t>
+            </a:r>
+            <a:endParaRPr lang="en-US"/>
+          </a:p>
+          <a:p>
+            <a:r>
+              <a:rPr lang="en-US"/>
+              <a:t>untuk menjalankan hasil menggunakan db container, bisa menggunakan syntax:</a:t>
+            </a:r>
+            <a:endParaRPr lang="en-US"/>
+          </a:p>
+          <a:p>
+            <a:pPr lvl="1"/>
             <a:r>
               <a:rPr lang="en-US" altLang="en-US"/>
-              <a:t>CREATE TABLE public.staff (</a:t>
-            </a:r>
-            <a:endParaRPr lang="en-US" altLang="en-US"/>
-          </a:p>
-          <a:p>
-            <a:pPr marL="0" indent="0">
-              <a:buNone/>
-            </a:pPr>
-            <a:r>
-              <a:rPr lang="en-US" altLang="en-US"/>
-              <a:t>	id bigserial NOT NULL PRIMARY KEY,</a:t>
-            </a:r>
-            <a:endParaRPr lang="en-US" altLang="en-US"/>
-          </a:p>
-          <a:p>
-            <a:pPr marL="0" indent="0">
-              <a:buNone/>
-            </a:pPr>
-            <a:r>
-              <a:rPr lang="en-US" altLang="en-US"/>
-              <a:t>    	name varchar(255) NOT NULL,</a:t>
-            </a:r>
-            <a:endParaRPr lang="en-US" altLang="en-US"/>
-          </a:p>
-          <a:p>
-            <a:pPr marL="0" indent="0">
-              <a:buNone/>
-            </a:pPr>
-            <a:r>
-              <a:rPr lang="en-US" altLang="en-US"/>
-              <a:t>    	position varchar(255) NOT NULL,</a:t>
-            </a:r>
-            <a:endParaRPr lang="en-US" altLang="en-US"/>
-          </a:p>
-          <a:p>
-            <a:pPr marL="0" indent="0">
-              <a:buNone/>
-            </a:pPr>
-            <a:r>
-              <a:rPr lang="en-US" altLang="en-US"/>
-              <a:t>   	join_date date NOT NULL,</a:t>
-            </a:r>
-            <a:endParaRPr lang="en-US" altLang="en-US"/>
-          </a:p>
-          <a:p>
-            <a:pPr marL="0" indent="0">
-              <a:buNone/>
-            </a:pPr>
-            <a:r>
-              <a:rPr lang="en-US" altLang="en-US"/>
-              <a:t>    	release_date date NULL,</a:t>
-            </a:r>
-            <a:endParaRPr lang="en-US" altLang="en-US"/>
-          </a:p>
-          <a:p>
-            <a:pPr marL="0" indent="0">
-              <a:buNone/>
-            </a:pPr>
-            <a:r>
-              <a:rPr lang="en-US" altLang="en-US"/>
-              <a:t>    	years_of_experience int NOT NULL,</a:t>
-            </a:r>
-            <a:endParaRPr lang="en-US" altLang="en-US"/>
-          </a:p>
-          <a:p>
-            <a:pPr marL="0" indent="0">
-              <a:buNone/>
-            </a:pPr>
-            <a:r>
-              <a:rPr lang="en-US" altLang="en-US"/>
-              <a:t>    	salary numeric(10, 2) NOT NULL</a:t>
-            </a:r>
-            <a:endParaRPr lang="en-US" altLang="en-US"/>
-          </a:p>
-          <a:p>
-            <a:pPr marL="0" indent="0">
-              <a:buNone/>
-            </a:pPr>
-            <a:r>
-              <a:rPr lang="en-US" altLang="en-US"/>
-              <a:t>);</a:t>
-            </a:r>
-            <a:endParaRPr lang="en-US" altLang="en-US"/>
-          </a:p>
-          <a:p>
-            <a:endParaRPr lang="en-US" altLang="en-US"/>
+              <a:t>docker exec -i hr_app_db psql -U app -d appdatabase -f /home/db_scripts/(nama file, misal task1.sql)</a:t>
+            </a:r>
+            <a:endParaRPr lang="en-US"/>
+          </a:p>
+          <a:p>
+            <a:endParaRPr lang="en-US"/>
           </a:p>
         </p:txBody>
       </p:sp>
@@ -4510,6 +4563,158 @@
 </file>
 
 <file path=ppt/slides/slide22.xml><?xml version="1.0" encoding="utf-8"?>
+<p:sld xmlns:a="http://schemas.openxmlformats.org/drawingml/2006/main" xmlns:r="http://schemas.openxmlformats.org/officeDocument/2006/relationships" xmlns:p="http://schemas.openxmlformats.org/presentationml/2006/main">
+  <p:cSld>
+    <p:spTree>
+      <p:nvGrpSpPr>
+        <p:cNvPr id="1" name=""/>
+        <p:cNvGrpSpPr/>
+        <p:nvPr/>
+      </p:nvGrpSpPr>
+      <p:grpSpPr/>
+      <p:sp>
+        <p:nvSpPr>
+          <p:cNvPr id="2" name="Title 1"/>
+          <p:cNvSpPr>
+            <a:spLocks noGrp="1"/>
+          </p:cNvSpPr>
+          <p:nvPr>
+            <p:ph type="title"/>
+          </p:nvPr>
+        </p:nvSpPr>
+        <p:spPr/>
+        <p:txBody>
+          <a:bodyPr>
+            <a:normAutofit fontScale="90000"/>
+          </a:bodyPr>
+          <a:p>
+            <a:r>
+              <a:rPr lang="en-US"/>
+              <a:t>asumsi tabel staff dengan sql create table sebagai berikut</a:t>
+            </a:r>
+            <a:endParaRPr lang="en-US"/>
+          </a:p>
+        </p:txBody>
+      </p:sp>
+      <p:sp>
+        <p:nvSpPr>
+          <p:cNvPr id="3" name="Content Placeholder 2"/>
+          <p:cNvSpPr>
+            <a:spLocks noGrp="1"/>
+          </p:cNvSpPr>
+          <p:nvPr>
+            <p:ph idx="1"/>
+          </p:nvPr>
+        </p:nvSpPr>
+        <p:spPr/>
+        <p:txBody>
+          <a:bodyPr>
+            <a:normAutofit lnSpcReduction="10000"/>
+          </a:bodyPr>
+          <a:p>
+            <a:pPr marL="0" indent="0">
+              <a:buNone/>
+            </a:pPr>
+            <a:r>
+              <a:rPr lang="en-US" altLang="en-US"/>
+              <a:t>CREATE TABLE public.staff (</a:t>
+            </a:r>
+            <a:endParaRPr lang="en-US" altLang="en-US"/>
+          </a:p>
+          <a:p>
+            <a:pPr marL="0" indent="0">
+              <a:buNone/>
+            </a:pPr>
+            <a:r>
+              <a:rPr lang="en-US" altLang="en-US"/>
+              <a:t>	id bigserial NOT NULL PRIMARY KEY,</a:t>
+            </a:r>
+            <a:endParaRPr lang="en-US" altLang="en-US"/>
+          </a:p>
+          <a:p>
+            <a:pPr marL="0" indent="0">
+              <a:buNone/>
+            </a:pPr>
+            <a:r>
+              <a:rPr lang="en-US" altLang="en-US"/>
+              <a:t>    	name varchar(255) NOT NULL,</a:t>
+            </a:r>
+            <a:endParaRPr lang="en-US" altLang="en-US"/>
+          </a:p>
+          <a:p>
+            <a:pPr marL="0" indent="0">
+              <a:buNone/>
+            </a:pPr>
+            <a:r>
+              <a:rPr lang="en-US" altLang="en-US"/>
+              <a:t>    	position varchar(255) NOT NULL,</a:t>
+            </a:r>
+            <a:endParaRPr lang="en-US" altLang="en-US"/>
+          </a:p>
+          <a:p>
+            <a:pPr marL="0" indent="0">
+              <a:buNone/>
+            </a:pPr>
+            <a:r>
+              <a:rPr lang="en-US" altLang="en-US"/>
+              <a:t>   	join_date date NOT NULL,</a:t>
+            </a:r>
+            <a:endParaRPr lang="en-US" altLang="en-US"/>
+          </a:p>
+          <a:p>
+            <a:pPr marL="0" indent="0">
+              <a:buNone/>
+            </a:pPr>
+            <a:r>
+              <a:rPr lang="en-US" altLang="en-US"/>
+              <a:t>    	release_date date NULL,</a:t>
+            </a:r>
+            <a:endParaRPr lang="en-US" altLang="en-US"/>
+          </a:p>
+          <a:p>
+            <a:pPr marL="0" indent="0">
+              <a:buNone/>
+            </a:pPr>
+            <a:r>
+              <a:rPr lang="en-US" altLang="en-US"/>
+              <a:t>    	years_of_experience int NOT NULL,</a:t>
+            </a:r>
+            <a:endParaRPr lang="en-US" altLang="en-US"/>
+          </a:p>
+          <a:p>
+            <a:pPr marL="0" indent="0">
+              <a:buNone/>
+            </a:pPr>
+            <a:r>
+              <a:rPr lang="en-US" altLang="en-US"/>
+              <a:t>    	salary numeric(10, 2) NOT NULL</a:t>
+            </a:r>
+            <a:endParaRPr lang="en-US" altLang="en-US"/>
+          </a:p>
+          <a:p>
+            <a:pPr marL="0" indent="0">
+              <a:buNone/>
+            </a:pPr>
+            <a:r>
+              <a:rPr lang="en-US" altLang="en-US"/>
+              <a:t>);</a:t>
+            </a:r>
+            <a:endParaRPr lang="en-US" altLang="en-US"/>
+          </a:p>
+          <a:p>
+            <a:endParaRPr lang="en-US" altLang="en-US"/>
+          </a:p>
+        </p:txBody>
+      </p:sp>
+    </p:spTree>
+  </p:cSld>
+  <p:clrMapOvr>
+    <a:masterClrMapping/>
+  </p:clrMapOvr>
+</p:sld>
+</file>
+
+<file path=ppt/slides/slide23.xml><?xml version="1.0" encoding="utf-8"?>
 <p:sld xmlns:a="http://schemas.openxmlformats.org/drawingml/2006/main" xmlns:r="http://schemas.openxmlformats.org/officeDocument/2006/relationships" xmlns:p="http://schemas.openxmlformats.org/presentationml/2006/main">
   <p:cSld>
     <p:spTree>
@@ -4575,7 +4780,7 @@
 </p:sld>
 </file>
 
-<file path=ppt/slides/slide23.xml><?xml version="1.0" encoding="utf-8"?>
+<file path=ppt/slides/slide24.xml><?xml version="1.0" encoding="utf-8"?>
 <p:sld xmlns:a="http://schemas.openxmlformats.org/drawingml/2006/main" xmlns:r="http://schemas.openxmlformats.org/officeDocument/2006/relationships" xmlns:p="http://schemas.openxmlformats.org/presentationml/2006/main">
   <p:cSld>
     <p:spTree>
@@ -4667,7 +4872,7 @@
 </p:sld>
 </file>
 
-<file path=ppt/slides/slide24.xml><?xml version="1.0" encoding="utf-8"?>
+<file path=ppt/slides/slide25.xml><?xml version="1.0" encoding="utf-8"?>
 <p:sld xmlns:a="http://schemas.openxmlformats.org/drawingml/2006/main" xmlns:r="http://schemas.openxmlformats.org/officeDocument/2006/relationships" xmlns:p="http://schemas.openxmlformats.org/presentationml/2006/main">
   <p:cSld>
     <p:spTree>
@@ -4759,7 +4964,7 @@
 </p:sld>
 </file>
 
-<file path=ppt/slides/slide25.xml><?xml version="1.0" encoding="utf-8"?>
+<file path=ppt/slides/slide26.xml><?xml version="1.0" encoding="utf-8"?>
 <p:sld xmlns:a="http://schemas.openxmlformats.org/drawingml/2006/main" xmlns:r="http://schemas.openxmlformats.org/officeDocument/2006/relationships" xmlns:p="http://schemas.openxmlformats.org/presentationml/2006/main">
   <p:cSld>
     <p:spTree>
@@ -4853,7 +5058,7 @@
 </p:sld>
 </file>
 
-<file path=ppt/slides/slide26.xml><?xml version="1.0" encoding="utf-8"?>
+<file path=ppt/slides/slide27.xml><?xml version="1.0" encoding="utf-8"?>
 <p:sld xmlns:a="http://schemas.openxmlformats.org/drawingml/2006/main" xmlns:r="http://schemas.openxmlformats.org/officeDocument/2006/relationships" xmlns:p="http://schemas.openxmlformats.org/presentationml/2006/main">
   <p:cSld>
     <p:spTree>
@@ -4945,7 +5150,7 @@
 </p:sld>
 </file>
 
-<file path=ppt/slides/slide27.xml><?xml version="1.0" encoding="utf-8"?>
+<file path=ppt/slides/slide28.xml><?xml version="1.0" encoding="utf-8"?>
 <p:sld xmlns:a="http://schemas.openxmlformats.org/drawingml/2006/main" xmlns:r="http://schemas.openxmlformats.org/officeDocument/2006/relationships" xmlns:p="http://schemas.openxmlformats.org/presentationml/2006/main">
   <p:cSld>
     <p:spTree>
@@ -5037,7 +5242,7 @@
 </p:sld>
 </file>
 
-<file path=ppt/slides/slide28.xml><?xml version="1.0" encoding="utf-8"?>
+<file path=ppt/slides/slide29.xml><?xml version="1.0" encoding="utf-8"?>
 <p:sld xmlns:a="http://schemas.openxmlformats.org/drawingml/2006/main" xmlns:r="http://schemas.openxmlformats.org/officeDocument/2006/relationships" xmlns:p="http://schemas.openxmlformats.org/presentationml/2006/main">
   <p:cSld>
     <p:spTree>
@@ -5129,68 +5334,6 @@
 </p:sld>
 </file>
 
-<file path=ppt/slides/slide29.xml><?xml version="1.0" encoding="utf-8"?>
-<p:sld xmlns:a="http://schemas.openxmlformats.org/drawingml/2006/main" xmlns:r="http://schemas.openxmlformats.org/officeDocument/2006/relationships" xmlns:p="http://schemas.openxmlformats.org/presentationml/2006/main">
-  <p:cSld>
-    <p:spTree>
-      <p:nvGrpSpPr>
-        <p:cNvPr id="1" name=""/>
-        <p:cNvGrpSpPr/>
-        <p:nvPr/>
-      </p:nvGrpSpPr>
-      <p:grpSpPr/>
-      <p:sp>
-        <p:nvSpPr>
-          <p:cNvPr id="5" name="Title 4"/>
-          <p:cNvSpPr>
-            <a:spLocks noGrp="1"/>
-          </p:cNvSpPr>
-          <p:nvPr>
-            <p:ph type="title"/>
-          </p:nvPr>
-        </p:nvSpPr>
-        <p:spPr/>
-        <p:txBody>
-          <a:bodyPr/>
-          <a:p>
-            <a:r>
-              <a:rPr lang="en-US"/>
-              <a:t>Contact person</a:t>
-            </a:r>
-            <a:endParaRPr lang="en-US"/>
-          </a:p>
-        </p:txBody>
-      </p:sp>
-      <p:sp>
-        <p:nvSpPr>
-          <p:cNvPr id="6" name="Content Placeholder 5"/>
-          <p:cNvSpPr>
-            <a:spLocks noGrp="1"/>
-          </p:cNvSpPr>
-          <p:nvPr>
-            <p:ph idx="1"/>
-          </p:nvPr>
-        </p:nvSpPr>
-        <p:spPr/>
-        <p:txBody>
-          <a:bodyPr/>
-          <a:p>
-            <a:r>
-              <a:rPr lang="en-US"/>
-              <a:t>jika terdapat kendala, dapat menghubungi email saya di jokevin.rachmadi@gmail.com</a:t>
-            </a:r>
-            <a:endParaRPr lang="en-US"/>
-          </a:p>
-        </p:txBody>
-      </p:sp>
-    </p:spTree>
-  </p:cSld>
-  <p:clrMapOvr>
-    <a:masterClrMapping/>
-  </p:clrMapOvr>
-</p:sld>
-</file>
-
 <file path=ppt/slides/slide3.xml><?xml version="1.0" encoding="utf-8"?>
 <p:sld xmlns:a="http://schemas.openxmlformats.org/drawingml/2006/main" xmlns:r="http://schemas.openxmlformats.org/officeDocument/2006/relationships" xmlns:p="http://schemas.openxmlformats.org/presentationml/2006/main">
   <p:cSld>
@@ -5217,7 +5360,7 @@
           <a:p>
             <a:r>
               <a:rPr lang="en-US"/>
-              <a:t>Docker</a:t>
+              <a:t>Instalasi</a:t>
             </a:r>
             <a:endParaRPr lang="en-US"/>
           </a:p>
@@ -5237,23 +5380,100 @@
         <p:txBody>
           <a:bodyPr/>
           <a:p>
-            <a:r>
-              <a:rPr lang="en-US"/>
-              <a:t>Penggunaan docker bertujuan untuk mengurangi ketidakcocokan yang terjadi saat program test akan diinstalasikan</a:t>
-            </a:r>
-            <a:endParaRPr lang="en-US"/>
-          </a:p>
-          <a:p>
-            <a:r>
-              <a:rPr lang="en-US"/>
-              <a:t>Penggunaan docker mempermudah instalasi karena mengurangi kebutuhan untuk menulis atau kebutuhan konfigurasi</a:t>
-            </a:r>
-            <a:endParaRPr lang="en-US"/>
-          </a:p>
-          <a:p>
-            <a:r>
-              <a:rPr lang="en-US"/>
-              <a:t>Penggunaan docker compose mempermudah developer melakukan konfigurasi dalam satu file</a:t>
+            <a:pPr lvl="1"/>
+            <a:r>
+              <a:rPr lang="en-US"/>
+              <a:t>setelah melakukan clone repositori, harap melakukan copy file .env.example ke .env </a:t>
+            </a:r>
+            <a:endParaRPr lang="en-US"/>
+          </a:p>
+          <a:p>
+            <a:pPr lvl="1"/>
+            <a:r>
+              <a:rPr lang="en-US"/>
+              <a:t>dalam file .env sesuaikan dengan port yang digunakan untuk app dan host db</a:t>
+            </a:r>
+            <a:endParaRPr lang="en-US"/>
+          </a:p>
+          <a:p>
+            <a:pPr lvl="1"/>
+            <a:r>
+              <a:rPr lang="en-US"/>
+              <a:t>jalankan “docker compose --build -d”</a:t>
+            </a:r>
+            <a:endParaRPr lang="en-US"/>
+          </a:p>
+          <a:p>
+            <a:pPr lvl="1"/>
+            <a:r>
+              <a:rPr lang="en-US"/>
+              <a:t>untuk menghentikan docker, menggunakan docker compose down </a:t>
+            </a:r>
+            <a:endParaRPr lang="en-US"/>
+          </a:p>
+          <a:p>
+            <a:pPr lvl="1"/>
+            <a:endParaRPr lang="en-US"/>
+          </a:p>
+        </p:txBody>
+      </p:sp>
+    </p:spTree>
+  </p:cSld>
+  <p:clrMapOvr>
+    <a:masterClrMapping/>
+  </p:clrMapOvr>
+</p:sld>
+</file>
+
+<file path=ppt/slides/slide30.xml><?xml version="1.0" encoding="utf-8"?>
+<p:sld xmlns:a="http://schemas.openxmlformats.org/drawingml/2006/main" xmlns:r="http://schemas.openxmlformats.org/officeDocument/2006/relationships" xmlns:p="http://schemas.openxmlformats.org/presentationml/2006/main">
+  <p:cSld>
+    <p:spTree>
+      <p:nvGrpSpPr>
+        <p:cNvPr id="1" name=""/>
+        <p:cNvGrpSpPr/>
+        <p:nvPr/>
+      </p:nvGrpSpPr>
+      <p:grpSpPr/>
+      <p:sp>
+        <p:nvSpPr>
+          <p:cNvPr id="5" name="Title 4"/>
+          <p:cNvSpPr>
+            <a:spLocks noGrp="1"/>
+          </p:cNvSpPr>
+          <p:nvPr>
+            <p:ph type="title"/>
+          </p:nvPr>
+        </p:nvSpPr>
+        <p:spPr/>
+        <p:txBody>
+          <a:bodyPr/>
+          <a:p>
+            <a:r>
+              <a:rPr lang="en-US"/>
+              <a:t>Contact person</a:t>
+            </a:r>
+            <a:endParaRPr lang="en-US"/>
+          </a:p>
+        </p:txBody>
+      </p:sp>
+      <p:sp>
+        <p:nvSpPr>
+          <p:cNvPr id="6" name="Content Placeholder 5"/>
+          <p:cNvSpPr>
+            <a:spLocks noGrp="1"/>
+          </p:cNvSpPr>
+          <p:nvPr>
+            <p:ph idx="1"/>
+          </p:nvPr>
+        </p:nvSpPr>
+        <p:spPr/>
+        <p:txBody>
+          <a:bodyPr/>
+          <a:p>
+            <a:r>
+              <a:rPr lang="en-US"/>
+              <a:t>jika terdapat kendala, dapat menghubungi email saya di jokevin.rachmadi@gmail.com</a:t>
             </a:r>
             <a:endParaRPr lang="en-US"/>
           </a:p>
@@ -5268,6 +5488,82 @@
 </file>
 
 <file path=ppt/slides/slide4.xml><?xml version="1.0" encoding="utf-8"?>
+<p:sld xmlns:a="http://schemas.openxmlformats.org/drawingml/2006/main" xmlns:r="http://schemas.openxmlformats.org/officeDocument/2006/relationships" xmlns:p="http://schemas.openxmlformats.org/presentationml/2006/main">
+  <p:cSld>
+    <p:spTree>
+      <p:nvGrpSpPr>
+        <p:cNvPr id="1" name=""/>
+        <p:cNvGrpSpPr/>
+        <p:nvPr/>
+      </p:nvGrpSpPr>
+      <p:grpSpPr/>
+      <p:sp>
+        <p:nvSpPr>
+          <p:cNvPr id="2" name="Title 1"/>
+          <p:cNvSpPr>
+            <a:spLocks noGrp="1"/>
+          </p:cNvSpPr>
+          <p:nvPr>
+            <p:ph type="title"/>
+          </p:nvPr>
+        </p:nvSpPr>
+        <p:spPr/>
+        <p:txBody>
+          <a:bodyPr/>
+          <a:p>
+            <a:r>
+              <a:rPr lang="en-US"/>
+              <a:t>Docker</a:t>
+            </a:r>
+            <a:endParaRPr lang="en-US"/>
+          </a:p>
+        </p:txBody>
+      </p:sp>
+      <p:sp>
+        <p:nvSpPr>
+          <p:cNvPr id="3" name="Content Placeholder 2"/>
+          <p:cNvSpPr>
+            <a:spLocks noGrp="1"/>
+          </p:cNvSpPr>
+          <p:nvPr>
+            <p:ph idx="1"/>
+          </p:nvPr>
+        </p:nvSpPr>
+        <p:spPr/>
+        <p:txBody>
+          <a:bodyPr/>
+          <a:p>
+            <a:r>
+              <a:rPr lang="en-US"/>
+              <a:t>Penggunaan docker bertujuan untuk mengurangi ketidakcocokan yang terjadi saat program test akan diinstalasikan</a:t>
+            </a:r>
+            <a:endParaRPr lang="en-US"/>
+          </a:p>
+          <a:p>
+            <a:r>
+              <a:rPr lang="en-US"/>
+              <a:t>Penggunaan docker mempermudah instalasi karena mengurangi kebutuhan untuk menulis atau kebutuhan konfigurasi</a:t>
+            </a:r>
+            <a:endParaRPr lang="en-US"/>
+          </a:p>
+          <a:p>
+            <a:r>
+              <a:rPr lang="en-US"/>
+              <a:t>Penggunaan docker compose mempermudah developer melakukan konfigurasi dalam satu file</a:t>
+            </a:r>
+            <a:endParaRPr lang="en-US"/>
+          </a:p>
+        </p:txBody>
+      </p:sp>
+    </p:spTree>
+  </p:cSld>
+  <p:clrMapOvr>
+    <a:masterClrMapping/>
+  </p:clrMapOvr>
+</p:sld>
+</file>
+
+<file path=ppt/slides/slide5.xml><?xml version="1.0" encoding="utf-8"?>
 <p:sld xmlns:a="http://schemas.openxmlformats.org/drawingml/2006/main" xmlns:r="http://schemas.openxmlformats.org/officeDocument/2006/relationships" xmlns:p="http://schemas.openxmlformats.org/presentationml/2006/main">
   <p:cSld>
     <p:spTree>
@@ -5360,7 +5656,7 @@
 </p:sld>
 </file>
 
-<file path=ppt/slides/slide5.xml><?xml version="1.0" encoding="utf-8"?>
+<file path=ppt/slides/slide6.xml><?xml version="1.0" encoding="utf-8"?>
 <p:sld xmlns:a="http://schemas.openxmlformats.org/drawingml/2006/main" xmlns:r="http://schemas.openxmlformats.org/officeDocument/2006/relationships" xmlns:p="http://schemas.openxmlformats.org/presentationml/2006/main">
   <p:cSld>
     <p:spTree>
@@ -5462,7 +5758,7 @@
 </p:sld>
 </file>
 
-<file path=ppt/slides/slide6.xml><?xml version="1.0" encoding="utf-8"?>
+<file path=ppt/slides/slide7.xml><?xml version="1.0" encoding="utf-8"?>
 <p:sld xmlns:a="http://schemas.openxmlformats.org/drawingml/2006/main" xmlns:r="http://schemas.openxmlformats.org/officeDocument/2006/relationships" xmlns:p="http://schemas.openxmlformats.org/presentationml/2006/main">
   <p:cSld>
     <p:spTree>
@@ -5574,7 +5870,7 @@
 </p:sld>
 </file>
 
-<file path=ppt/slides/slide7.xml><?xml version="1.0" encoding="utf-8"?>
+<file path=ppt/slides/slide8.xml><?xml version="1.0" encoding="utf-8"?>
 <p:sld xmlns:a="http://schemas.openxmlformats.org/drawingml/2006/main" xmlns:r="http://schemas.openxmlformats.org/officeDocument/2006/relationships" xmlns:p="http://schemas.openxmlformats.org/presentationml/2006/main">
   <p:cSld>
     <p:spTree>
@@ -5742,7 +6038,7 @@
 </p:sld>
 </file>
 
-<file path=ppt/slides/slide8.xml><?xml version="1.0" encoding="utf-8"?>
+<file path=ppt/slides/slide9.xml><?xml version="1.0" encoding="utf-8"?>
 <p:sld xmlns:a="http://schemas.openxmlformats.org/drawingml/2006/main" xmlns:r="http://schemas.openxmlformats.org/officeDocument/2006/relationships" xmlns:p="http://schemas.openxmlformats.org/presentationml/2006/main">
   <p:cSld>
     <p:spTree>
@@ -5796,210 +6092,6 @@
           <a:xfrm>
             <a:off x="2387600" y="1825625"/>
             <a:ext cx="7415530" cy="4351655"/>
-          </a:xfrm>
-          <a:prstGeom prst="rect">
-            <a:avLst/>
-          </a:prstGeom>
-        </p:spPr>
-      </p:pic>
-    </p:spTree>
-  </p:cSld>
-  <p:clrMapOvr>
-    <a:masterClrMapping/>
-  </p:clrMapOvr>
-</p:sld>
-</file>
-
-<file path=ppt/slides/slide9.xml><?xml version="1.0" encoding="utf-8"?>
-<p:sld xmlns:a="http://schemas.openxmlformats.org/drawingml/2006/main" xmlns:r="http://schemas.openxmlformats.org/officeDocument/2006/relationships" xmlns:p="http://schemas.openxmlformats.org/presentationml/2006/main">
-  <p:cSld>
-    <p:spTree>
-      <p:nvGrpSpPr>
-        <p:cNvPr id="1" name=""/>
-        <p:cNvGrpSpPr/>
-        <p:nvPr/>
-      </p:nvGrpSpPr>
-      <p:grpSpPr/>
-      <p:sp>
-        <p:nvSpPr>
-          <p:cNvPr id="2" name="Title 1"/>
-          <p:cNvSpPr>
-            <a:spLocks noGrp="1"/>
-          </p:cNvSpPr>
-          <p:nvPr>
-            <p:ph type="title"/>
-          </p:nvPr>
-        </p:nvSpPr>
-        <p:spPr/>
-        <p:txBody>
-          <a:bodyPr/>
-          <a:p>
-            <a:r>
-              <a:rPr lang="en-US"/>
-              <a:t>API Update Applicants</a:t>
-            </a:r>
-            <a:endParaRPr lang="en-US"/>
-          </a:p>
-        </p:txBody>
-      </p:sp>
-      <p:sp>
-        <p:nvSpPr>
-          <p:cNvPr id="3" name="Content Placeholder 2"/>
-          <p:cNvSpPr>
-            <a:spLocks noGrp="1"/>
-          </p:cNvSpPr>
-          <p:nvPr>
-            <p:ph sz="half" idx="1"/>
-          </p:nvPr>
-        </p:nvSpPr>
-        <p:spPr/>
-        <p:txBody>
-          <a:bodyPr>
-            <a:normAutofit fontScale="60000"/>
-          </a:bodyPr>
-          <a:p>
-            <a:r>
-              <a:rPr lang="en-US">
-                <a:sym typeface="+mn-ea"/>
-              </a:rPr>
-              <a:t>Api untuk mengupdate data aplicants</a:t>
-            </a:r>
-            <a:endParaRPr lang="en-US">
-              <a:sym typeface="+mn-ea"/>
-            </a:endParaRPr>
-          </a:p>
-          <a:p>
-            <a:r>
-              <a:rPr lang="en-US">
-                <a:sym typeface="+mn-ea"/>
-              </a:rPr>
-              <a:t>Method POST</a:t>
-            </a:r>
-            <a:endParaRPr lang="en-US"/>
-          </a:p>
-          <a:p>
-            <a:r>
-              <a:rPr lang="en-US">
-                <a:sym typeface="+mn-ea"/>
-              </a:rPr>
-              <a:t>URL:</a:t>
-            </a:r>
-            <a:br>
-              <a:rPr lang="en-US">
-                <a:sym typeface="+mn-ea"/>
-              </a:rPr>
-            </a:br>
-            <a:r>
-              <a:rPr lang="en-US">
-                <a:sym typeface="+mn-ea"/>
-              </a:rPr>
-              <a:t>localhost:3000/applicants/&lt;id applicants&gt;</a:t>
-            </a:r>
-            <a:endParaRPr lang="en-US">
-              <a:sym typeface="+mn-ea"/>
-            </a:endParaRPr>
-          </a:p>
-          <a:p>
-            <a:r>
-              <a:rPr lang="en-US">
-                <a:sym typeface="+mn-ea"/>
-              </a:rPr>
-              <a:t>Contoh url:</a:t>
-            </a:r>
-            <a:br>
-              <a:rPr lang="en-US">
-                <a:sym typeface="+mn-ea"/>
-              </a:rPr>
-            </a:br>
-            <a:r>
-              <a:rPr lang="en-US">
-                <a:sym typeface="+mn-ea"/>
-              </a:rPr>
-              <a:t>localhost:3000/applicants/11</a:t>
-            </a:r>
-            <a:endParaRPr lang="en-US"/>
-          </a:p>
-          <a:p>
-            <a:r>
-              <a:rPr lang="en-US" altLang="en-US">
-                <a:sym typeface="+mn-ea"/>
-              </a:rPr>
-              <a:t>Contoh body:</a:t>
-            </a:r>
-            <a:endParaRPr lang="en-US" altLang="en-US"/>
-          </a:p>
-          <a:p>
-            <a:pPr marL="0" indent="0">
-              <a:buNone/>
-            </a:pPr>
-            <a:r>
-              <a:rPr lang="en-US" altLang="en-US"/>
-              <a:t>{</a:t>
-            </a:r>
-            <a:endParaRPr lang="en-US" altLang="en-US"/>
-          </a:p>
-          <a:p>
-            <a:pPr marL="0" indent="0">
-              <a:buNone/>
-            </a:pPr>
-            <a:r>
-              <a:rPr lang="en-US" altLang="en-US"/>
-              <a:t>    "name": "Joshua Kevin Updated",</a:t>
-            </a:r>
-            <a:endParaRPr lang="en-US" altLang="en-US"/>
-          </a:p>
-          <a:p>
-            <a:pPr marL="0" indent="0">
-              <a:buNone/>
-            </a:pPr>
-            <a:r>
-              <a:rPr lang="en-US" altLang="en-US"/>
-              <a:t>    "email": "jokevin@example.com",</a:t>
-            </a:r>
-            <a:endParaRPr lang="en-US" altLang="en-US"/>
-          </a:p>
-          <a:p>
-            <a:pPr marL="0" indent="0">
-              <a:buNone/>
-            </a:pPr>
-            <a:r>
-              <a:rPr lang="en-US" altLang="en-US"/>
-              <a:t>    "phone": "081234567891"</a:t>
-            </a:r>
-            <a:endParaRPr lang="en-US" altLang="en-US"/>
-          </a:p>
-          <a:p>
-            <a:pPr marL="0" indent="0">
-              <a:buNone/>
-            </a:pPr>
-            <a:r>
-              <a:rPr lang="en-US" altLang="en-US"/>
-              <a:t>}</a:t>
-            </a:r>
-            <a:endParaRPr lang="en-US" altLang="en-US"/>
-          </a:p>
-        </p:txBody>
-      </p:sp>
-      <p:pic>
-        <p:nvPicPr>
-          <p:cNvPr id="5" name="Content Placeholder 4"/>
-          <p:cNvPicPr>
-            <a:picLocks noChangeAspect="1"/>
-          </p:cNvPicPr>
-          <p:nvPr>
-            <p:ph sz="half" idx="2"/>
-          </p:nvPr>
-        </p:nvPicPr>
-        <p:blipFill>
-          <a:blip r:embed="rId1"/>
-          <a:stretch>
-            <a:fillRect/>
-          </a:stretch>
-        </p:blipFill>
-        <p:spPr>
-          <a:xfrm>
-            <a:off x="6660515" y="1825625"/>
-            <a:ext cx="4204335" cy="4351655"/>
           </a:xfrm>
           <a:prstGeom prst="rect">
             <a:avLst/>

</xml_diff>